<commit_message>
Fix known issues in pptx
</commit_message>
<xml_diff>
--- a/samples/pptx/pptx_small_grouped_notes.pptx
+++ b/samples/pptx/pptx_small_grouped_notes.pptx
@@ -4166,12 +4166,40 @@
         <p:nvSpPr>
           <p:cNvPr id="171" name="Highlights"/>
           <p:cNvSpPr txBox="1"/>
+          <p:nvPr>
+            <p:ph type="ctrTitle"/>
+          </p:nvPr>
+        </p:nvSpPr>
+        <p:spPr>
+          <a:xfrm>
+            <a:off x="469681" y="-533451"/>
+            <a:ext cx="21971004" cy="4648201"/>
+          </a:xfrm>
+          <a:prstGeom prst="rect">
+            <a:avLst/>
+          </a:prstGeom>
+        </p:spPr>
+        <p:txBody>
+          <a:bodyPr/>
+          <a:lstStyle/>
+          <a:p>
+            <a:pPr/>
+            <a:r>
+              <a:t>Highlights</a:t>
+            </a:r>
+          </a:p>
+        </p:txBody>
+      </p:sp>
+      <p:sp>
+        <p:nvSpPr>
+          <p:cNvPr id="172" name="Item A"/>
+          <p:cNvSpPr txBox="1"/>
           <p:nvPr/>
         </p:nvSpPr>
         <p:spPr>
           <a:xfrm>
-            <a:off x="8737650" y="61715"/>
-            <a:ext cx="6908700" cy="1849568"/>
+            <a:off x="11536527" y="4880051"/>
+            <a:ext cx="1876045" cy="808432"/>
           </a:xfrm>
           <a:prstGeom prst="rect">
             <a:avLst/>
@@ -4189,35 +4217,25 @@
           <a:bodyPr wrap="none" lIns="50800" tIns="50800" rIns="50800" bIns="50800" anchor="ctr">
             <a:spAutoFit/>
           </a:bodyPr>
-          <a:lstStyle>
-            <a:lvl1pPr>
-              <a:lnSpc>
-                <a:spcPct val="80000"/>
-              </a:lnSpc>
-              <a:spcBef>
-                <a:spcPts val="0"/>
-              </a:spcBef>
-              <a:defRPr b="1" spc="-232" sz="11600"/>
-            </a:lvl1pPr>
-          </a:lstStyle>
-          <a:p>
-            <a:pPr/>
-            <a:r>
-              <a:t>Highlights</a:t>
-            </a:r>
-          </a:p>
-        </p:txBody>
-      </p:sp>
-      <p:sp>
-        <p:nvSpPr>
-          <p:cNvPr id="172" name="Item A"/>
+          <a:lstStyle/>
+          <a:p>
+            <a:pPr/>
+            <a:r>
+              <a:t>Item A</a:t>
+            </a:r>
+          </a:p>
+        </p:txBody>
+      </p:sp>
+      <p:sp>
+        <p:nvSpPr>
+          <p:cNvPr id="173" name="Item B"/>
           <p:cNvSpPr txBox="1"/>
           <p:nvPr/>
         </p:nvSpPr>
         <p:spPr>
           <a:xfrm>
-            <a:off x="11253977" y="6037583"/>
-            <a:ext cx="1876045" cy="808433"/>
+            <a:off x="11525250" y="5618345"/>
+            <a:ext cx="1898600" cy="808433"/>
           </a:xfrm>
           <a:prstGeom prst="rect">
             <a:avLst/>
@@ -4239,21 +4257,21 @@
           <a:p>
             <a:pPr/>
             <a:r>
-              <a:t>Item A</a:t>
-            </a:r>
-          </a:p>
-        </p:txBody>
-      </p:sp>
-      <p:sp>
-        <p:nvSpPr>
-          <p:cNvPr id="173" name="Item B"/>
+              <a:t>Item B</a:t>
+            </a:r>
+          </a:p>
+        </p:txBody>
+      </p:sp>
+      <p:sp>
+        <p:nvSpPr>
+          <p:cNvPr id="174" name="Item C"/>
           <p:cNvSpPr txBox="1"/>
           <p:nvPr/>
         </p:nvSpPr>
         <p:spPr>
           <a:xfrm>
-            <a:off x="11242700" y="6730090"/>
-            <a:ext cx="1898600" cy="808432"/>
+            <a:off x="11513972" y="6453784"/>
+            <a:ext cx="1921155" cy="808432"/>
           </a:xfrm>
           <a:prstGeom prst="rect">
             <a:avLst/>
@@ -4275,42 +4293,6 @@
           <a:p>
             <a:pPr/>
             <a:r>
-              <a:t>Item B</a:t>
-            </a:r>
-          </a:p>
-        </p:txBody>
-      </p:sp>
-      <p:sp>
-        <p:nvSpPr>
-          <p:cNvPr id="174" name="Item C"/>
-          <p:cNvSpPr txBox="1"/>
-          <p:nvPr/>
-        </p:nvSpPr>
-        <p:spPr>
-          <a:xfrm>
-            <a:off x="11231422" y="7443880"/>
-            <a:ext cx="1921156" cy="808432"/>
-          </a:xfrm>
-          <a:prstGeom prst="rect">
-            <a:avLst/>
-          </a:prstGeom>
-          <a:ln w="12700">
-            <a:miter lim="400000"/>
-          </a:ln>
-          <a:extLst>
-            <a:ext uri="{C572A759-6A51-4108-AA02-DFA0A04FC94B}">
-              <ma14:wrappingTextBoxFlag xmlns:ma14="http://schemas.microsoft.com/office/mac/drawingml/2011/main" val="1"/>
-            </a:ext>
-          </a:extLst>
-        </p:spPr>
-        <p:txBody>
-          <a:bodyPr wrap="none" lIns="50800" tIns="50800" rIns="50800" bIns="50800" anchor="ctr">
-            <a:spAutoFit/>
-          </a:bodyPr>
-          <a:lstStyle/>
-          <a:p>
-            <a:pPr/>
-            <a:r>
               <a:t>Item C</a:t>
             </a:r>
           </a:p>
@@ -4324,8 +4306,8 @@
         </p:nvSpPr>
         <p:spPr>
           <a:xfrm>
-            <a:off x="196706" y="12532515"/>
-            <a:ext cx="4416248" cy="808432"/>
+            <a:off x="634190" y="12417387"/>
+            <a:ext cx="4416248" cy="808433"/>
           </a:xfrm>
           <a:prstGeom prst="rect">
             <a:avLst/>

</xml_diff>